<commit_message>
feat(roadtrip): ajoute la slide budget avec camembert
Nouvelle slide 28 « Le budget, poste par poste » : camembert PowerPoint
natif (donc éditable) en cinq postes, tableau détaillé des montants et
totaux par personne et par jour.

Chiffrage indicatif reconstruit sur hypothèses explicites — 4 personnes,
13 jours en août, départ de Genève, logements avec cuisine, repas
préparés soi-même — soit ≈ 7 150 € au total. Les montants se modifient
dans POSTES en tête du bloc budget de build/deck.js.

Les cinq couleurs des tranches passent les contrôles d'accessibilité
dans l'ordre du camembert, bouclage compris, avec étiquettes directes
et tableau de valeurs en second encodage.

PDF régénéré (29 pages).

Co-Authored-By: Claude Opus 5 <noreply@anthropic.com>
Claude-Session: https://claude.ai/code/session_012dBA3Qrtn9kognkW1dJtYm
</commit_message>
<xml_diff>
--- a/roadtrip-scandinavie/Roadtrip-Scandinavie-12-nuits.pptx
+++ b/roadtrip-scandinavie/Roadtrip-Scandinavie-12-nuits.pptx
@@ -33,9 +33,10 @@
     <p:sldId id="281" r:id="rId27"/>
     <p:sldId id="282" r:id="rId28"/>
     <p:sldId id="283" r:id="rId29"/>
+    <p:sldId id="284" r:id="rId30"/>
   </p:sldIdLst>
   <p:notesMasterIdLst>
-    <p:notesMasterId r:id="rId30"/>
+    <p:notesMasterId r:id="rId31"/>
   </p:notesMasterIdLst>
   <p:sldSz cx="12192000" cy="6858000"/>
   <p:notesSz cx="6858000" cy="12192000"/>
@@ -132,6 +133,356 @@
     </a:lvl9pPr>
   </p:defaultTextStyle>
 </p:presentation>
+</file>
+
+<file path=ppt/charts/chart1.xml><?xml version="1.0" encoding="utf-8"?>
+<c:chartSpace xmlns:c="http://schemas.openxmlformats.org/drawingml/2006/chart" xmlns:a="http://schemas.openxmlformats.org/drawingml/2006/main" xmlns:r="http://schemas.openxmlformats.org/officeDocument/2006/relationships">
+  <c:date1904 val="0"/>
+  <c:roundedCorners val="1"/>
+  <c:chart>
+    <c:autoTitleDeleted val="1"/>
+    <c:plotArea>
+      <c:layout/>
+      <c:pieChart>
+        <c:varyColors val="1"/>
+        <c:ser>
+          <c:idx val="0"/>
+          <c:order val="0"/>
+          <c:tx>
+            <c:strRef>
+              <c:f>Sheet1!$B$1</c:f>
+              <c:strCache>
+                <c:ptCount val="1"/>
+                <c:pt idx="0">
+                  <c:v>Budget</c:v>
+                </c:pt>
+              </c:strCache>
+            </c:strRef>
+          </c:tx>
+          <c:spPr>
+            <a:solidFill>
+              <a:schemeClr val="accent1"/>
+            </a:solidFill>
+            <a:ln w="9525" cap="flat">
+              <a:solidFill>
+                <a:srgbClr val="F9F9F9"/>
+              </a:solidFill>
+              <a:prstDash val="solid"/>
+              <a:round/>
+            </a:ln>
+            <a:effectLst/>
+          </c:spPr>
+          <c:dPt>
+            <c:idx val="0"/>
+            <c:bubble3D val="0"/>
+            <c:spPr>
+              <a:solidFill>
+                <a:srgbClr val="A83E27"/>
+              </a:solidFill>
+              <a:ln w="25400" cap="flat">
+                <a:solidFill>
+                  <a:srgbClr val="FFFFFF"/>
+                </a:solidFill>
+                <a:prstDash val="solid"/>
+                <a:round/>
+              </a:ln>
+              <a:effectLst/>
+            </c:spPr>
+          </c:dPt>
+          <c:dPt>
+            <c:idx val="1"/>
+            <c:bubble3D val="0"/>
+            <c:spPr>
+              <a:solidFill>
+                <a:srgbClr val="2A78D6"/>
+              </a:solidFill>
+              <a:ln w="25400" cap="flat">
+                <a:solidFill>
+                  <a:srgbClr val="FFFFFF"/>
+                </a:solidFill>
+                <a:prstDash val="solid"/>
+                <a:round/>
+              </a:ln>
+              <a:effectLst/>
+            </c:spPr>
+          </c:dPt>
+          <c:dPt>
+            <c:idx val="2"/>
+            <c:bubble3D val="0"/>
+            <c:spPr>
+              <a:solidFill>
+                <a:srgbClr val="C98500"/>
+              </a:solidFill>
+              <a:ln w="25400" cap="flat">
+                <a:solidFill>
+                  <a:srgbClr val="FFFFFF"/>
+                </a:solidFill>
+                <a:prstDash val="solid"/>
+                <a:round/>
+              </a:ln>
+              <a:effectLst/>
+            </c:spPr>
+          </c:dPt>
+          <c:dPt>
+            <c:idx val="3"/>
+            <c:bubble3D val="0"/>
+            <c:spPr>
+              <a:solidFill>
+                <a:srgbClr val="00958C"/>
+              </a:solidFill>
+              <a:ln w="25400" cap="flat">
+                <a:solidFill>
+                  <a:srgbClr val="FFFFFF"/>
+                </a:solidFill>
+                <a:prstDash val="solid"/>
+                <a:round/>
+              </a:ln>
+              <a:effectLst/>
+            </c:spPr>
+          </c:dPt>
+          <c:dPt>
+            <c:idx val="4"/>
+            <c:bubble3D val="0"/>
+            <c:spPr>
+              <a:solidFill>
+                <a:srgbClr val="7B4FA0"/>
+              </a:solidFill>
+              <a:ln w="25400" cap="flat">
+                <a:solidFill>
+                  <a:srgbClr val="FFFFFF"/>
+                </a:solidFill>
+                <a:prstDash val="solid"/>
+                <a:round/>
+              </a:ln>
+              <a:effectLst/>
+            </c:spPr>
+          </c:dPt>
+          <c:dLbls>
+            <c:dLbl>
+              <c:idx val="0"/>
+              <c:numFmt formatCode="0&quot; &quot;%" sourceLinked="0"/>
+              <c:spPr/>
+              <c:txPr>
+                <a:bodyPr/>
+                <a:lstStyle/>
+                <a:p>
+                  <a:pPr>
+                    <a:defRPr sz="1200" b="1" i="0" u="none" strike="noStrike">
+                      <a:solidFill>
+                        <a:srgbClr val="0F2E36"/>
+                      </a:solidFill>
+                      <a:latin typeface="Calibri"/>
+                    </a:defRPr>
+                  </a:pPr>
+                </a:p>
+              </c:txPr>
+              <c:dLblPos val="outEnd"/>
+              <c:showLegendKey val="0"/>
+              <c:showVal val="0"/>
+              <c:showCatName val="0"/>
+              <c:showSerName val="0"/>
+              <c:showPercent val="1"/>
+              <c:showBubbleSize val="0"/>
+            </c:dLbl>
+            <c:dLbl>
+              <c:idx val="1"/>
+              <c:numFmt formatCode="0&quot; &quot;%" sourceLinked="0"/>
+              <c:spPr/>
+              <c:txPr>
+                <a:bodyPr/>
+                <a:lstStyle/>
+                <a:p>
+                  <a:pPr>
+                    <a:defRPr sz="1200" b="1" i="0" u="none" strike="noStrike">
+                      <a:solidFill>
+                        <a:srgbClr val="0F2E36"/>
+                      </a:solidFill>
+                      <a:latin typeface="Calibri"/>
+                    </a:defRPr>
+                  </a:pPr>
+                </a:p>
+              </c:txPr>
+              <c:dLblPos val="outEnd"/>
+              <c:showLegendKey val="0"/>
+              <c:showVal val="0"/>
+              <c:showCatName val="0"/>
+              <c:showSerName val="0"/>
+              <c:showPercent val="1"/>
+              <c:showBubbleSize val="0"/>
+            </c:dLbl>
+            <c:dLbl>
+              <c:idx val="2"/>
+              <c:numFmt formatCode="0&quot; &quot;%" sourceLinked="0"/>
+              <c:spPr/>
+              <c:txPr>
+                <a:bodyPr/>
+                <a:lstStyle/>
+                <a:p>
+                  <a:pPr>
+                    <a:defRPr sz="1200" b="1" i="0" u="none" strike="noStrike">
+                      <a:solidFill>
+                        <a:srgbClr val="0F2E36"/>
+                      </a:solidFill>
+                      <a:latin typeface="Calibri"/>
+                    </a:defRPr>
+                  </a:pPr>
+                </a:p>
+              </c:txPr>
+              <c:dLblPos val="outEnd"/>
+              <c:showLegendKey val="0"/>
+              <c:showVal val="0"/>
+              <c:showCatName val="0"/>
+              <c:showSerName val="0"/>
+              <c:showPercent val="1"/>
+              <c:showBubbleSize val="0"/>
+            </c:dLbl>
+            <c:dLbl>
+              <c:idx val="3"/>
+              <c:numFmt formatCode="0&quot; &quot;%" sourceLinked="0"/>
+              <c:spPr/>
+              <c:txPr>
+                <a:bodyPr/>
+                <a:lstStyle/>
+                <a:p>
+                  <a:pPr>
+                    <a:defRPr sz="1200" b="1" i="0" u="none" strike="noStrike">
+                      <a:solidFill>
+                        <a:srgbClr val="0F2E36"/>
+                      </a:solidFill>
+                      <a:latin typeface="Calibri"/>
+                    </a:defRPr>
+                  </a:pPr>
+                </a:p>
+              </c:txPr>
+              <c:dLblPos val="outEnd"/>
+              <c:showLegendKey val="0"/>
+              <c:showVal val="0"/>
+              <c:showCatName val="0"/>
+              <c:showSerName val="0"/>
+              <c:showPercent val="1"/>
+              <c:showBubbleSize val="0"/>
+            </c:dLbl>
+            <c:dLbl>
+              <c:idx val="4"/>
+              <c:numFmt formatCode="0&quot; &quot;%" sourceLinked="0"/>
+              <c:spPr/>
+              <c:txPr>
+                <a:bodyPr/>
+                <a:lstStyle/>
+                <a:p>
+                  <a:pPr>
+                    <a:defRPr sz="1200" b="1" i="0" u="none" strike="noStrike">
+                      <a:solidFill>
+                        <a:srgbClr val="0F2E36"/>
+                      </a:solidFill>
+                      <a:latin typeface="Calibri"/>
+                    </a:defRPr>
+                  </a:pPr>
+                </a:p>
+              </c:txPr>
+              <c:dLblPos val="outEnd"/>
+              <c:showLegendKey val="0"/>
+              <c:showVal val="0"/>
+              <c:showCatName val="0"/>
+              <c:showSerName val="0"/>
+              <c:showPercent val="1"/>
+              <c:showBubbleSize val="0"/>
+            </c:dLbl>
+            <c:numFmt formatCode="0&quot; &quot;%" sourceLinked="0"/>
+            <c:txPr>
+              <a:bodyPr/>
+              <a:lstStyle/>
+              <a:p>
+                <a:pPr>
+                  <a:defRPr sz="1800" b="1" i="0" u="none" strike="noStrike">
+                    <a:solidFill>
+                      <a:srgbClr val="000000"/>
+                    </a:solidFill>
+                    <a:latin typeface="Arial"/>
+                  </a:defRPr>
+                </a:pPr>
+              </a:p>
+            </c:txPr>
+            <c:dLblPos val="ctr"/>
+            <c:showLegendKey val="0"/>
+            <c:showVal val="0"/>
+            <c:showCatName val="1"/>
+            <c:showSerName val="0"/>
+            <c:showPercent val="1"/>
+            <c:showBubbleSize val="0"/>
+            <c:showLeaderLines val="0"/>
+          </c:dLbls>
+          <c:cat>
+            <c:strRef>
+              <c:f>Sheet1!$A$2:$A$6</c:f>
+              <c:strCache>
+                <c:ptCount val="5"/>
+                <c:pt idx="0">
+                  <c:v>Hébergement</c:v>
+                </c:pt>
+                <c:pt idx="1">
+                  <c:v>Voiture</c:v>
+                </c:pt>
+                <c:pt idx="2">
+                  <c:v>Vols</c:v>
+                </c:pt>
+                <c:pt idx="3">
+                  <c:v>Courses et repas</c:v>
+                </c:pt>
+                <c:pt idx="4">
+                  <c:v>Activités</c:v>
+                </c:pt>
+              </c:strCache>
+            </c:strRef>
+          </c:cat>
+          <c:val>
+            <c:numRef>
+              <c:f>Sheet1!$B$2:$B$6</c:f>
+              <c:numCache>
+                <c:ptCount val="5"/>
+                <c:pt idx="0">
+                  <c:v>2800</c:v>
+                </c:pt>
+                <c:pt idx="1">
+                  <c:v>1250</c:v>
+                </c:pt>
+                <c:pt idx="2">
+                  <c:v>1150</c:v>
+                </c:pt>
+                <c:pt idx="3">
+                  <c:v>1000</c:v>
+                </c:pt>
+                <c:pt idx="4">
+                  <c:v>950</c:v>
+                </c:pt>
+              </c:numCache>
+            </c:numRef>
+          </c:val>
+        </c:ser>
+        <c:firstSliceAng val="0"/>
+      </c:pieChart>
+      <c:spPr>
+        <a:noFill/>
+        <a:ln>
+          <a:noFill/>
+        </a:ln>
+        <a:effectLst/>
+      </c:spPr>
+    </c:plotArea>
+    <c:plotVisOnly val="1"/>
+    <c:dispBlanksAs val="span"/>
+  </c:chart>
+  <c:spPr>
+    <a:noFill/>
+    <a:ln>
+      <a:noFill/>
+    </a:ln>
+    <a:effectLst/>
+  </c:spPr>
+  <c:externalData r:id="rId1">
+    <c:autoUpdate val="0"/>
+  </c:externalData>
+</c:chartSpace>
 </file>
 
 <file path=ppt/notesMasters/notesMaster1.xml><?xml version="1.0" encoding="utf-8"?>
@@ -2289,7 +2640,7 @@
           <a:p>
             <a:r>
               <a:rPr lang="en-US" dirty="0"/>
-              <a:t>Compatible avec l’ensemble des contraintes fixées au départ.</a:t>
+              <a:t>Hypothèses : 4 personnes, 12 nuits, août, départ Genève, logements avec cuisine, repas maison. Vols multi-destinations. Voiture prise le jour 3 et rendue le jour 11.</a:t>
             </a:r>
             <a:endParaRPr lang="en-US" dirty="0"/>
           </a:p>
@@ -2313,6 +2664,94 @@
             <a:fld id="{F7021451-1387-4CA6-816F-3879F97B5CBC}" type="slidenum">
               <a:rPr lang="en-US"/>
               <a:t>28</a:t>
+            </a:fld>
+            <a:endParaRPr lang="en-US"/>
+          </a:p>
+        </p:txBody>
+      </p:sp>
+    </p:spTree>
+    <p:extLst>
+      <p:ext uri="{BB962C8B-B14F-4D97-AF65-F5344CB8AC3E}">
+        <p14:creationId xmlns:p14="http://schemas.microsoft.com/office/powerpoint/2010/main" val="1024086991"/>
+      </p:ext>
+    </p:extLst>
+  </p:cSld>
+  <p:clrMapOvr>
+    <a:masterClrMapping/>
+  </p:clrMapOvr>
+</p:notes>
+</file>
+
+<file path=ppt/notesSlides/notesSlide29.xml><?xml version="1.0" encoding="utf-8"?>
+<p:notes xmlns:a="http://schemas.openxmlformats.org/drawingml/2006/main" xmlns:r="http://schemas.openxmlformats.org/officeDocument/2006/relationships" xmlns:p="http://schemas.openxmlformats.org/presentationml/2006/main">
+  <p:cSld>
+    <p:spTree>
+      <p:nvGrpSpPr>
+        <p:cNvPr id="1" name=""/>
+        <p:cNvGrpSpPr/>
+        <p:nvPr/>
+      </p:nvGrpSpPr>
+      <p:grpSpPr>
+        <a:xfrm>
+          <a:off x="0" y="0"/>
+          <a:ext cx="0" cy="0"/>
+          <a:chOff x="0" y="0"/>
+          <a:chExt cx="0" cy="0"/>
+        </a:xfrm>
+      </p:grpSpPr>
+      <p:sp>
+        <p:nvSpPr>
+          <p:cNvPr id="2" name="Slide Image Placeholder 1"/>
+          <p:cNvSpPr>
+            <a:spLocks noGrp="1" noRot="1" noChangeAspect="1"/>
+          </p:cNvSpPr>
+          <p:nvPr>
+            <p:ph type="sldImg"/>
+          </p:nvPr>
+        </p:nvSpPr>
+        <p:spPr/>
+      </p:sp>
+      <p:sp>
+        <p:nvSpPr>
+          <p:cNvPr id="3" name="Notes Placeholder 2"/>
+          <p:cNvSpPr>
+            <a:spLocks noGrp="1"/>
+          </p:cNvSpPr>
+          <p:nvPr>
+            <p:ph type="body" idx="1"/>
+          </p:nvPr>
+        </p:nvSpPr>
+        <p:spPr/>
+        <p:txBody>
+          <a:bodyPr/>
+          <a:lstStyle/>
+          <a:p>
+            <a:r>
+              <a:rPr lang="en-US" dirty="0"/>
+              <a:t>Compatible avec l’ensemble des contraintes fixées au départ.</a:t>
+            </a:r>
+            <a:endParaRPr lang="en-US" dirty="0"/>
+          </a:p>
+        </p:txBody>
+      </p:sp>
+      <p:sp>
+        <p:nvSpPr>
+          <p:cNvPr id="4" name="Slide Number Placeholder 3"/>
+          <p:cNvSpPr>
+            <a:spLocks noGrp="1"/>
+          </p:cNvSpPr>
+          <p:nvPr>
+            <p:ph type="sldNum" sz="quarter" idx="10"/>
+          </p:nvPr>
+        </p:nvSpPr>
+        <p:spPr/>
+        <p:txBody>
+          <a:bodyPr/>
+          <a:lstStyle/>
+          <a:p>
+            <a:fld id="{F7021451-1387-4CA6-816F-3879F97B5CBC}" type="slidenum">
+              <a:rPr lang="en-US"/>
+              <a:t>29</a:t>
             </a:fld>
             <a:endParaRPr lang="en-US"/>
           </a:p>
@@ -15283,6 +15722,1285 @@
     <p:bg>
       <p:bgPr>
         <a:solidFill>
+          <a:srgbClr val="FFFFFF"/>
+        </a:solidFill>
+      </p:bgPr>
+    </p:bg>
+    <p:spTree>
+      <p:nvGrpSpPr>
+        <p:cNvPr id="1" name=""/>
+        <p:cNvGrpSpPr/>
+        <p:nvPr/>
+      </p:nvGrpSpPr>
+      <p:grpSpPr>
+        <a:xfrm>
+          <a:off x="0" y="0"/>
+          <a:ext cx="0" cy="0"/>
+          <a:chOff x="0" y="0"/>
+          <a:chExt cx="0" cy="0"/>
+        </a:xfrm>
+      </p:grpSpPr>
+      <p:sp>
+        <p:nvSpPr>
+          <p:cNvPr id="2" name="Text 0"/>
+          <p:cNvSpPr txBox="1"/>
+          <p:nvPr/>
+        </p:nvSpPr>
+        <p:spPr>
+          <a:xfrm>
+            <a:off x="566928" y="548640"/>
+            <a:ext cx="6400800" cy="237744"/>
+          </a:xfrm>
+          <a:prstGeom prst="rect">
+            <a:avLst/>
+          </a:prstGeom>
+          <a:noFill/>
+          <a:ln/>
+        </p:spPr>
+        <p:txBody>
+          <a:bodyPr wrap="square" lIns="0" tIns="0" rIns="0" bIns="0" rtlCol="0" anchor="ctr"/>
+          <a:lstStyle/>
+          <a:p>
+            <a:pPr indent="0" marL="0">
+              <a:buNone/>
+            </a:pPr>
+            <a:r>
+              <a:rPr lang="en-US" sz="1100" b="1" spc="220" kern="0" dirty="0">
+                <a:solidFill>
+                  <a:srgbClr val="A83E27"/>
+                </a:solidFill>
+                <a:latin typeface="Calibri" pitchFamily="34" charset="0"/>
+                <a:ea typeface="Calibri" pitchFamily="34" charset="-122"/>
+                <a:cs typeface="Calibri" pitchFamily="34" charset="-120"/>
+              </a:rPr>
+              <a:t>ORDRE DE GRANDEUR</a:t>
+            </a:r>
+            <a:endParaRPr lang="en-US" sz="1100" dirty="0"/>
+          </a:p>
+        </p:txBody>
+      </p:sp>
+      <p:sp>
+        <p:nvSpPr>
+          <p:cNvPr id="3" name="Text 1"/>
+          <p:cNvSpPr txBox="1"/>
+          <p:nvPr/>
+        </p:nvSpPr>
+        <p:spPr>
+          <a:xfrm>
+            <a:off x="566928" y="868680"/>
+            <a:ext cx="10424160" cy="777240"/>
+          </a:xfrm>
+          <a:prstGeom prst="rect">
+            <a:avLst/>
+          </a:prstGeom>
+          <a:noFill/>
+          <a:ln/>
+        </p:spPr>
+        <p:txBody>
+          <a:bodyPr wrap="square" lIns="0" tIns="0" rIns="0" bIns="0" rtlCol="0" anchor="ctr"/>
+          <a:lstStyle/>
+          <a:p>
+            <a:pPr indent="0" marL="0">
+              <a:buNone/>
+            </a:pPr>
+            <a:r>
+              <a:rPr lang="en-US" sz="3300" b="1" dirty="0">
+                <a:solidFill>
+                  <a:srgbClr val="0F2E36"/>
+                </a:solidFill>
+                <a:latin typeface="Cambria" pitchFamily="34" charset="0"/>
+                <a:ea typeface="Cambria" pitchFamily="34" charset="-122"/>
+                <a:cs typeface="Cambria" pitchFamily="34" charset="-120"/>
+              </a:rPr>
+              <a:t>Le budget, poste par poste</a:t>
+            </a:r>
+            <a:endParaRPr lang="en-US" sz="3300" dirty="0"/>
+          </a:p>
+        </p:txBody>
+      </p:sp>
+      <p:sp>
+        <p:nvSpPr>
+          <p:cNvPr id="4" name="Text 2"/>
+          <p:cNvSpPr txBox="1"/>
+          <p:nvPr/>
+        </p:nvSpPr>
+        <p:spPr>
+          <a:xfrm>
+            <a:off x="566928" y="1700784"/>
+            <a:ext cx="9692640" cy="475488"/>
+          </a:xfrm>
+          <a:prstGeom prst="rect">
+            <a:avLst/>
+          </a:prstGeom>
+          <a:noFill/>
+          <a:ln/>
+        </p:spPr>
+        <p:txBody>
+          <a:bodyPr wrap="square" lIns="0" tIns="0" rIns="0" bIns="0" rtlCol="0" anchor="ctr"/>
+          <a:lstStyle/>
+          <a:p>
+            <a:pPr indent="0" marL="0">
+              <a:lnSpc>
+                <a:spcPct val="115000"/>
+              </a:lnSpc>
+              <a:buNone/>
+            </a:pPr>
+            <a:r>
+              <a:rPr lang="en-US" sz="1500" dirty="0">
+                <a:solidFill>
+                  <a:srgbClr val="5F757B"/>
+                </a:solidFill>
+                <a:latin typeface="Calibri" pitchFamily="34" charset="0"/>
+                <a:ea typeface="Calibri" pitchFamily="34" charset="-122"/>
+                <a:cs typeface="Calibri" pitchFamily="34" charset="-120"/>
+              </a:rPr>
+              <a:t>Quatre personnes, 13 jours en août, départ de Genève : bons logements équipés d’une cuisine, repas préparés soi-même.</a:t>
+            </a:r>
+            <a:endParaRPr lang="en-US" sz="1500" dirty="0"/>
+          </a:p>
+        </p:txBody>
+      </p:sp>
+      <p:graphicFrame>
+        <p:nvGraphicFramePr>
+          <p:cNvPr id="5" name="Chart 0" descr=""/>
+          <p:cNvGraphicFramePr/>
+          <p:nvPr/>
+        </p:nvGraphicFramePr>
+        <p:xfrm>
+          <a:off x="502920" y="2194560"/>
+          <a:ext cx="5394960" cy="3931920"/>
+        </p:xfrm>
+        <a:graphic xmlns:a="http://schemas.openxmlformats.org/drawingml/2006/main">
+          <a:graphicData uri="http://schemas.openxmlformats.org/drawingml/2006/chart">
+            <c:chart xmlns:c="http://schemas.openxmlformats.org/drawingml/2006/chart" r:id="rId1"/>
+          </a:graphicData>
+        </a:graphic>
+      </p:graphicFrame>
+      <p:sp>
+        <p:nvSpPr>
+          <p:cNvPr id="6" name="Shape 3"/>
+          <p:cNvSpPr/>
+          <p:nvPr/>
+        </p:nvSpPr>
+        <p:spPr>
+          <a:xfrm>
+            <a:off x="6053328" y="2450592"/>
+            <a:ext cx="201168" cy="201168"/>
+          </a:xfrm>
+          <a:prstGeom prst="roundRect">
+            <a:avLst>
+              <a:gd name="adj" fmla="val 18182"/>
+            </a:avLst>
+          </a:prstGeom>
+          <a:solidFill>
+            <a:srgbClr val="A83E27"/>
+          </a:solidFill>
+          <a:ln/>
+        </p:spPr>
+      </p:sp>
+      <p:sp>
+        <p:nvSpPr>
+          <p:cNvPr id="7" name="Text 4"/>
+          <p:cNvSpPr txBox="1"/>
+          <p:nvPr/>
+        </p:nvSpPr>
+        <p:spPr>
+          <a:xfrm>
+            <a:off x="6400800" y="2395728"/>
+            <a:ext cx="2240280" cy="274320"/>
+          </a:xfrm>
+          <a:prstGeom prst="rect">
+            <a:avLst/>
+          </a:prstGeom>
+          <a:noFill/>
+          <a:ln/>
+        </p:spPr>
+        <p:txBody>
+          <a:bodyPr wrap="square" lIns="0" tIns="0" rIns="0" bIns="0" rtlCol="0" anchor="ctr"/>
+          <a:lstStyle/>
+          <a:p>
+            <a:pPr indent="0" marL="0">
+              <a:buNone/>
+            </a:pPr>
+            <a:r>
+              <a:rPr lang="en-US" sz="1400" b="1" dirty="0">
+                <a:solidFill>
+                  <a:srgbClr val="0F2E36"/>
+                </a:solidFill>
+                <a:latin typeface="Calibri" pitchFamily="34" charset="0"/>
+                <a:ea typeface="Calibri" pitchFamily="34" charset="-122"/>
+                <a:cs typeface="Calibri" pitchFamily="34" charset="-120"/>
+              </a:rPr>
+              <a:t>Hébergement</a:t>
+            </a:r>
+            <a:endParaRPr lang="en-US" sz="1400" dirty="0"/>
+          </a:p>
+        </p:txBody>
+      </p:sp>
+      <p:sp>
+        <p:nvSpPr>
+          <p:cNvPr id="8" name="Text 5"/>
+          <p:cNvSpPr txBox="1"/>
+          <p:nvPr/>
+        </p:nvSpPr>
+        <p:spPr>
+          <a:xfrm>
+            <a:off x="6400800" y="2651760"/>
+            <a:ext cx="3200400" cy="237744"/>
+          </a:xfrm>
+          <a:prstGeom prst="rect">
+            <a:avLst/>
+          </a:prstGeom>
+          <a:noFill/>
+          <a:ln/>
+        </p:spPr>
+        <p:txBody>
+          <a:bodyPr wrap="square" lIns="0" tIns="0" rIns="0" bIns="0" rtlCol="0" anchor="ctr"/>
+          <a:lstStyle/>
+          <a:p>
+            <a:pPr indent="0" marL="0">
+              <a:buNone/>
+            </a:pPr>
+            <a:r>
+              <a:rPr lang="en-US" sz="1050" dirty="0">
+                <a:solidFill>
+                  <a:srgbClr val="5F757B"/>
+                </a:solidFill>
+                <a:latin typeface="Calibri" pitchFamily="34" charset="0"/>
+                <a:ea typeface="Calibri" pitchFamily="34" charset="-122"/>
+                <a:cs typeface="Calibri" pitchFamily="34" charset="-120"/>
+              </a:rPr>
+              <a:t>12 nuits, 4 logements avec cuisine</a:t>
+            </a:r>
+            <a:endParaRPr lang="en-US" sz="1050" dirty="0"/>
+          </a:p>
+        </p:txBody>
+      </p:sp>
+      <p:sp>
+        <p:nvSpPr>
+          <p:cNvPr id="9" name="Text 6"/>
+          <p:cNvSpPr txBox="1"/>
+          <p:nvPr/>
+        </p:nvSpPr>
+        <p:spPr>
+          <a:xfrm>
+            <a:off x="9646920" y="2395728"/>
+            <a:ext cx="1188720" cy="274320"/>
+          </a:xfrm>
+          <a:prstGeom prst="rect">
+            <a:avLst/>
+          </a:prstGeom>
+          <a:noFill/>
+          <a:ln/>
+        </p:spPr>
+        <p:txBody>
+          <a:bodyPr wrap="square" lIns="0" tIns="0" rIns="0" bIns="0" rtlCol="0" anchor="ctr"/>
+          <a:lstStyle/>
+          <a:p>
+            <a:pPr algn="r" indent="0" marL="0">
+              <a:buNone/>
+            </a:pPr>
+            <a:r>
+              <a:rPr lang="en-US" sz="1500" b="1" dirty="0">
+                <a:solidFill>
+                  <a:srgbClr val="0F2E36"/>
+                </a:solidFill>
+                <a:latin typeface="Calibri" pitchFamily="34" charset="0"/>
+                <a:ea typeface="Calibri" pitchFamily="34" charset="-122"/>
+                <a:cs typeface="Calibri" pitchFamily="34" charset="-120"/>
+              </a:rPr>
+              <a:t>2 800 €</a:t>
+            </a:r>
+            <a:endParaRPr lang="en-US" sz="1500" dirty="0"/>
+          </a:p>
+        </p:txBody>
+      </p:sp>
+      <p:sp>
+        <p:nvSpPr>
+          <p:cNvPr id="10" name="Text 7"/>
+          <p:cNvSpPr txBox="1"/>
+          <p:nvPr/>
+        </p:nvSpPr>
+        <p:spPr>
+          <a:xfrm>
+            <a:off x="10927080" y="2414016"/>
+            <a:ext cx="658368" cy="256032"/>
+          </a:xfrm>
+          <a:prstGeom prst="rect">
+            <a:avLst/>
+          </a:prstGeom>
+          <a:noFill/>
+          <a:ln/>
+        </p:spPr>
+        <p:txBody>
+          <a:bodyPr wrap="square" lIns="0" tIns="0" rIns="0" bIns="0" rtlCol="0" anchor="ctr"/>
+          <a:lstStyle/>
+          <a:p>
+            <a:pPr algn="r" indent="0" marL="0">
+              <a:buNone/>
+            </a:pPr>
+            <a:r>
+              <a:rPr lang="en-US" sz="1250" dirty="0">
+                <a:solidFill>
+                  <a:srgbClr val="5F757B"/>
+                </a:solidFill>
+                <a:latin typeface="Calibri" pitchFamily="34" charset="0"/>
+                <a:ea typeface="Calibri" pitchFamily="34" charset="-122"/>
+                <a:cs typeface="Calibri" pitchFamily="34" charset="-120"/>
+              </a:rPr>
+              <a:t>39 %</a:t>
+            </a:r>
+            <a:endParaRPr lang="en-US" sz="1250" dirty="0"/>
+          </a:p>
+        </p:txBody>
+      </p:sp>
+      <p:sp>
+        <p:nvSpPr>
+          <p:cNvPr id="11" name="Shape 8"/>
+          <p:cNvSpPr/>
+          <p:nvPr/>
+        </p:nvSpPr>
+        <p:spPr>
+          <a:xfrm>
+            <a:off x="6053328" y="2999232"/>
+            <a:ext cx="201168" cy="201168"/>
+          </a:xfrm>
+          <a:prstGeom prst="roundRect">
+            <a:avLst>
+              <a:gd name="adj" fmla="val 18182"/>
+            </a:avLst>
+          </a:prstGeom>
+          <a:solidFill>
+            <a:srgbClr val="2A78D6"/>
+          </a:solidFill>
+          <a:ln/>
+        </p:spPr>
+      </p:sp>
+      <p:sp>
+        <p:nvSpPr>
+          <p:cNvPr id="12" name="Text 9"/>
+          <p:cNvSpPr txBox="1"/>
+          <p:nvPr/>
+        </p:nvSpPr>
+        <p:spPr>
+          <a:xfrm>
+            <a:off x="6400800" y="2944368"/>
+            <a:ext cx="2240280" cy="274320"/>
+          </a:xfrm>
+          <a:prstGeom prst="rect">
+            <a:avLst/>
+          </a:prstGeom>
+          <a:noFill/>
+          <a:ln/>
+        </p:spPr>
+        <p:txBody>
+          <a:bodyPr wrap="square" lIns="0" tIns="0" rIns="0" bIns="0" rtlCol="0" anchor="ctr"/>
+          <a:lstStyle/>
+          <a:p>
+            <a:pPr indent="0" marL="0">
+              <a:buNone/>
+            </a:pPr>
+            <a:r>
+              <a:rPr lang="en-US" sz="1400" b="1" dirty="0">
+                <a:solidFill>
+                  <a:srgbClr val="0F2E36"/>
+                </a:solidFill>
+                <a:latin typeface="Calibri" pitchFamily="34" charset="0"/>
+                <a:ea typeface="Calibri" pitchFamily="34" charset="-122"/>
+                <a:cs typeface="Calibri" pitchFamily="34" charset="-120"/>
+              </a:rPr>
+              <a:t>Voiture</a:t>
+            </a:r>
+            <a:endParaRPr lang="en-US" sz="1400" dirty="0"/>
+          </a:p>
+        </p:txBody>
+      </p:sp>
+      <p:sp>
+        <p:nvSpPr>
+          <p:cNvPr id="13" name="Text 10"/>
+          <p:cNvSpPr txBox="1"/>
+          <p:nvPr/>
+        </p:nvSpPr>
+        <p:spPr>
+          <a:xfrm>
+            <a:off x="6400800" y="3200400"/>
+            <a:ext cx="3200400" cy="237744"/>
+          </a:xfrm>
+          <a:prstGeom prst="rect">
+            <a:avLst/>
+          </a:prstGeom>
+          <a:noFill/>
+          <a:ln/>
+        </p:spPr>
+        <p:txBody>
+          <a:bodyPr wrap="square" lIns="0" tIns="0" rIns="0" bIns="0" rtlCol="0" anchor="ctr"/>
+          <a:lstStyle/>
+          <a:p>
+            <a:pPr indent="0" marL="0">
+              <a:buNone/>
+            </a:pPr>
+            <a:r>
+              <a:rPr lang="en-US" sz="1050" dirty="0">
+                <a:solidFill>
+                  <a:srgbClr val="5F757B"/>
+                </a:solidFill>
+                <a:latin typeface="Calibri" pitchFamily="34" charset="0"/>
+                <a:ea typeface="Calibri" pitchFamily="34" charset="-122"/>
+                <a:cs typeface="Calibri" pitchFamily="34" charset="-120"/>
+              </a:rPr>
+              <a:t>9 jours, abandon en Suède, carburant, Øresund</a:t>
+            </a:r>
+            <a:endParaRPr lang="en-US" sz="1050" dirty="0"/>
+          </a:p>
+        </p:txBody>
+      </p:sp>
+      <p:sp>
+        <p:nvSpPr>
+          <p:cNvPr id="14" name="Text 11"/>
+          <p:cNvSpPr txBox="1"/>
+          <p:nvPr/>
+        </p:nvSpPr>
+        <p:spPr>
+          <a:xfrm>
+            <a:off x="9646920" y="2944368"/>
+            <a:ext cx="1188720" cy="274320"/>
+          </a:xfrm>
+          <a:prstGeom prst="rect">
+            <a:avLst/>
+          </a:prstGeom>
+          <a:noFill/>
+          <a:ln/>
+        </p:spPr>
+        <p:txBody>
+          <a:bodyPr wrap="square" lIns="0" tIns="0" rIns="0" bIns="0" rtlCol="0" anchor="ctr"/>
+          <a:lstStyle/>
+          <a:p>
+            <a:pPr algn="r" indent="0" marL="0">
+              <a:buNone/>
+            </a:pPr>
+            <a:r>
+              <a:rPr lang="en-US" sz="1500" b="1" dirty="0">
+                <a:solidFill>
+                  <a:srgbClr val="0F2E36"/>
+                </a:solidFill>
+                <a:latin typeface="Calibri" pitchFamily="34" charset="0"/>
+                <a:ea typeface="Calibri" pitchFamily="34" charset="-122"/>
+                <a:cs typeface="Calibri" pitchFamily="34" charset="-120"/>
+              </a:rPr>
+              <a:t>1 250 €</a:t>
+            </a:r>
+            <a:endParaRPr lang="en-US" sz="1500" dirty="0"/>
+          </a:p>
+        </p:txBody>
+      </p:sp>
+      <p:sp>
+        <p:nvSpPr>
+          <p:cNvPr id="15" name="Text 12"/>
+          <p:cNvSpPr txBox="1"/>
+          <p:nvPr/>
+        </p:nvSpPr>
+        <p:spPr>
+          <a:xfrm>
+            <a:off x="10927080" y="2962656"/>
+            <a:ext cx="658368" cy="256032"/>
+          </a:xfrm>
+          <a:prstGeom prst="rect">
+            <a:avLst/>
+          </a:prstGeom>
+          <a:noFill/>
+          <a:ln/>
+        </p:spPr>
+        <p:txBody>
+          <a:bodyPr wrap="square" lIns="0" tIns="0" rIns="0" bIns="0" rtlCol="0" anchor="ctr"/>
+          <a:lstStyle/>
+          <a:p>
+            <a:pPr algn="r" indent="0" marL="0">
+              <a:buNone/>
+            </a:pPr>
+            <a:r>
+              <a:rPr lang="en-US" sz="1250" dirty="0">
+                <a:solidFill>
+                  <a:srgbClr val="5F757B"/>
+                </a:solidFill>
+                <a:latin typeface="Calibri" pitchFamily="34" charset="0"/>
+                <a:ea typeface="Calibri" pitchFamily="34" charset="-122"/>
+                <a:cs typeface="Calibri" pitchFamily="34" charset="-120"/>
+              </a:rPr>
+              <a:t>17 %</a:t>
+            </a:r>
+            <a:endParaRPr lang="en-US" sz="1250" dirty="0"/>
+          </a:p>
+        </p:txBody>
+      </p:sp>
+      <p:sp>
+        <p:nvSpPr>
+          <p:cNvPr id="16" name="Shape 13"/>
+          <p:cNvSpPr/>
+          <p:nvPr/>
+        </p:nvSpPr>
+        <p:spPr>
+          <a:xfrm>
+            <a:off x="6053328" y="3547872"/>
+            <a:ext cx="201168" cy="201168"/>
+          </a:xfrm>
+          <a:prstGeom prst="roundRect">
+            <a:avLst>
+              <a:gd name="adj" fmla="val 18182"/>
+            </a:avLst>
+          </a:prstGeom>
+          <a:solidFill>
+            <a:srgbClr val="C98500"/>
+          </a:solidFill>
+          <a:ln/>
+        </p:spPr>
+      </p:sp>
+      <p:sp>
+        <p:nvSpPr>
+          <p:cNvPr id="17" name="Text 14"/>
+          <p:cNvSpPr txBox="1"/>
+          <p:nvPr/>
+        </p:nvSpPr>
+        <p:spPr>
+          <a:xfrm>
+            <a:off x="6400800" y="3493008"/>
+            <a:ext cx="2240280" cy="274320"/>
+          </a:xfrm>
+          <a:prstGeom prst="rect">
+            <a:avLst/>
+          </a:prstGeom>
+          <a:noFill/>
+          <a:ln/>
+        </p:spPr>
+        <p:txBody>
+          <a:bodyPr wrap="square" lIns="0" tIns="0" rIns="0" bIns="0" rtlCol="0" anchor="ctr"/>
+          <a:lstStyle/>
+          <a:p>
+            <a:pPr indent="0" marL="0">
+              <a:buNone/>
+            </a:pPr>
+            <a:r>
+              <a:rPr lang="en-US" sz="1400" b="1" dirty="0">
+                <a:solidFill>
+                  <a:srgbClr val="0F2E36"/>
+                </a:solidFill>
+                <a:latin typeface="Calibri" pitchFamily="34" charset="0"/>
+                <a:ea typeface="Calibri" pitchFamily="34" charset="-122"/>
+                <a:cs typeface="Calibri" pitchFamily="34" charset="-120"/>
+              </a:rPr>
+              <a:t>Vols</a:t>
+            </a:r>
+            <a:endParaRPr lang="en-US" sz="1400" dirty="0"/>
+          </a:p>
+        </p:txBody>
+      </p:sp>
+      <p:sp>
+        <p:nvSpPr>
+          <p:cNvPr id="18" name="Text 15"/>
+          <p:cNvSpPr txBox="1"/>
+          <p:nvPr/>
+        </p:nvSpPr>
+        <p:spPr>
+          <a:xfrm>
+            <a:off x="6400800" y="3749040"/>
+            <a:ext cx="3200400" cy="237744"/>
+          </a:xfrm>
+          <a:prstGeom prst="rect">
+            <a:avLst/>
+          </a:prstGeom>
+          <a:noFill/>
+          <a:ln/>
+        </p:spPr>
+        <p:txBody>
+          <a:bodyPr wrap="square" lIns="0" tIns="0" rIns="0" bIns="0" rtlCol="0" anchor="ctr"/>
+          <a:lstStyle/>
+          <a:p>
+            <a:pPr indent="0" marL="0">
+              <a:buNone/>
+            </a:pPr>
+            <a:r>
+              <a:rPr lang="en-US" sz="1050" dirty="0">
+                <a:solidFill>
+                  <a:srgbClr val="5F757B"/>
+                </a:solidFill>
+                <a:latin typeface="Calibri" pitchFamily="34" charset="0"/>
+                <a:ea typeface="Calibri" pitchFamily="34" charset="-122"/>
+                <a:cs typeface="Calibri" pitchFamily="34" charset="-120"/>
+              </a:rPr>
+              <a:t>Genève – Copenhague, Stockholm – Genève</a:t>
+            </a:r>
+            <a:endParaRPr lang="en-US" sz="1050" dirty="0"/>
+          </a:p>
+        </p:txBody>
+      </p:sp>
+      <p:sp>
+        <p:nvSpPr>
+          <p:cNvPr id="19" name="Text 16"/>
+          <p:cNvSpPr txBox="1"/>
+          <p:nvPr/>
+        </p:nvSpPr>
+        <p:spPr>
+          <a:xfrm>
+            <a:off x="9646920" y="3493008"/>
+            <a:ext cx="1188720" cy="274320"/>
+          </a:xfrm>
+          <a:prstGeom prst="rect">
+            <a:avLst/>
+          </a:prstGeom>
+          <a:noFill/>
+          <a:ln/>
+        </p:spPr>
+        <p:txBody>
+          <a:bodyPr wrap="square" lIns="0" tIns="0" rIns="0" bIns="0" rtlCol="0" anchor="ctr"/>
+          <a:lstStyle/>
+          <a:p>
+            <a:pPr algn="r" indent="0" marL="0">
+              <a:buNone/>
+            </a:pPr>
+            <a:r>
+              <a:rPr lang="en-US" sz="1500" b="1" dirty="0">
+                <a:solidFill>
+                  <a:srgbClr val="0F2E36"/>
+                </a:solidFill>
+                <a:latin typeface="Calibri" pitchFamily="34" charset="0"/>
+                <a:ea typeface="Calibri" pitchFamily="34" charset="-122"/>
+                <a:cs typeface="Calibri" pitchFamily="34" charset="-120"/>
+              </a:rPr>
+              <a:t>1 150 €</a:t>
+            </a:r>
+            <a:endParaRPr lang="en-US" sz="1500" dirty="0"/>
+          </a:p>
+        </p:txBody>
+      </p:sp>
+      <p:sp>
+        <p:nvSpPr>
+          <p:cNvPr id="20" name="Text 17"/>
+          <p:cNvSpPr txBox="1"/>
+          <p:nvPr/>
+        </p:nvSpPr>
+        <p:spPr>
+          <a:xfrm>
+            <a:off x="10927080" y="3511296"/>
+            <a:ext cx="658368" cy="256032"/>
+          </a:xfrm>
+          <a:prstGeom prst="rect">
+            <a:avLst/>
+          </a:prstGeom>
+          <a:noFill/>
+          <a:ln/>
+        </p:spPr>
+        <p:txBody>
+          <a:bodyPr wrap="square" lIns="0" tIns="0" rIns="0" bIns="0" rtlCol="0" anchor="ctr"/>
+          <a:lstStyle/>
+          <a:p>
+            <a:pPr algn="r" indent="0" marL="0">
+              <a:buNone/>
+            </a:pPr>
+            <a:r>
+              <a:rPr lang="en-US" sz="1250" dirty="0">
+                <a:solidFill>
+                  <a:srgbClr val="5F757B"/>
+                </a:solidFill>
+                <a:latin typeface="Calibri" pitchFamily="34" charset="0"/>
+                <a:ea typeface="Calibri" pitchFamily="34" charset="-122"/>
+                <a:cs typeface="Calibri" pitchFamily="34" charset="-120"/>
+              </a:rPr>
+              <a:t>16 %</a:t>
+            </a:r>
+            <a:endParaRPr lang="en-US" sz="1250" dirty="0"/>
+          </a:p>
+        </p:txBody>
+      </p:sp>
+      <p:sp>
+        <p:nvSpPr>
+          <p:cNvPr id="21" name="Shape 18"/>
+          <p:cNvSpPr/>
+          <p:nvPr/>
+        </p:nvSpPr>
+        <p:spPr>
+          <a:xfrm>
+            <a:off x="6053328" y="4096512"/>
+            <a:ext cx="201168" cy="201168"/>
+          </a:xfrm>
+          <a:prstGeom prst="roundRect">
+            <a:avLst>
+              <a:gd name="adj" fmla="val 18182"/>
+            </a:avLst>
+          </a:prstGeom>
+          <a:solidFill>
+            <a:srgbClr val="00958C"/>
+          </a:solidFill>
+          <a:ln/>
+        </p:spPr>
+      </p:sp>
+      <p:sp>
+        <p:nvSpPr>
+          <p:cNvPr id="22" name="Text 19"/>
+          <p:cNvSpPr txBox="1"/>
+          <p:nvPr/>
+        </p:nvSpPr>
+        <p:spPr>
+          <a:xfrm>
+            <a:off x="6400800" y="4041648"/>
+            <a:ext cx="2240280" cy="274320"/>
+          </a:xfrm>
+          <a:prstGeom prst="rect">
+            <a:avLst/>
+          </a:prstGeom>
+          <a:noFill/>
+          <a:ln/>
+        </p:spPr>
+        <p:txBody>
+          <a:bodyPr wrap="square" lIns="0" tIns="0" rIns="0" bIns="0" rtlCol="0" anchor="ctr"/>
+          <a:lstStyle/>
+          <a:p>
+            <a:pPr indent="0" marL="0">
+              <a:buNone/>
+            </a:pPr>
+            <a:r>
+              <a:rPr lang="en-US" sz="1400" b="1" dirty="0">
+                <a:solidFill>
+                  <a:srgbClr val="0F2E36"/>
+                </a:solidFill>
+                <a:latin typeface="Calibri" pitchFamily="34" charset="0"/>
+                <a:ea typeface="Calibri" pitchFamily="34" charset="-122"/>
+                <a:cs typeface="Calibri" pitchFamily="34" charset="-120"/>
+              </a:rPr>
+              <a:t>Courses et repas</a:t>
+            </a:r>
+            <a:endParaRPr lang="en-US" sz="1400" dirty="0"/>
+          </a:p>
+        </p:txBody>
+      </p:sp>
+      <p:sp>
+        <p:nvSpPr>
+          <p:cNvPr id="23" name="Text 20"/>
+          <p:cNvSpPr txBox="1"/>
+          <p:nvPr/>
+        </p:nvSpPr>
+        <p:spPr>
+          <a:xfrm>
+            <a:off x="6400800" y="4297680"/>
+            <a:ext cx="3200400" cy="237744"/>
+          </a:xfrm>
+          <a:prstGeom prst="rect">
+            <a:avLst/>
+          </a:prstGeom>
+          <a:noFill/>
+          <a:ln/>
+        </p:spPr>
+        <p:txBody>
+          <a:bodyPr wrap="square" lIns="0" tIns="0" rIns="0" bIns="0" rtlCol="0" anchor="ctr"/>
+          <a:lstStyle/>
+          <a:p>
+            <a:pPr indent="0" marL="0">
+              <a:buNone/>
+            </a:pPr>
+            <a:r>
+              <a:rPr lang="en-US" sz="1050" dirty="0">
+                <a:solidFill>
+                  <a:srgbClr val="5F757B"/>
+                </a:solidFill>
+                <a:latin typeface="Calibri" pitchFamily="34" charset="0"/>
+                <a:ea typeface="Calibri" pitchFamily="34" charset="-122"/>
+                <a:cs typeface="Calibri" pitchFamily="34" charset="-120"/>
+              </a:rPr>
+              <a:t>On cuisine ; quelques cafés et glaces</a:t>
+            </a:r>
+            <a:endParaRPr lang="en-US" sz="1050" dirty="0"/>
+          </a:p>
+        </p:txBody>
+      </p:sp>
+      <p:sp>
+        <p:nvSpPr>
+          <p:cNvPr id="24" name="Text 21"/>
+          <p:cNvSpPr txBox="1"/>
+          <p:nvPr/>
+        </p:nvSpPr>
+        <p:spPr>
+          <a:xfrm>
+            <a:off x="9646920" y="4041648"/>
+            <a:ext cx="1188720" cy="274320"/>
+          </a:xfrm>
+          <a:prstGeom prst="rect">
+            <a:avLst/>
+          </a:prstGeom>
+          <a:noFill/>
+          <a:ln/>
+        </p:spPr>
+        <p:txBody>
+          <a:bodyPr wrap="square" lIns="0" tIns="0" rIns="0" bIns="0" rtlCol="0" anchor="ctr"/>
+          <a:lstStyle/>
+          <a:p>
+            <a:pPr algn="r" indent="0" marL="0">
+              <a:buNone/>
+            </a:pPr>
+            <a:r>
+              <a:rPr lang="en-US" sz="1500" b="1" dirty="0">
+                <a:solidFill>
+                  <a:srgbClr val="0F2E36"/>
+                </a:solidFill>
+                <a:latin typeface="Calibri" pitchFamily="34" charset="0"/>
+                <a:ea typeface="Calibri" pitchFamily="34" charset="-122"/>
+                <a:cs typeface="Calibri" pitchFamily="34" charset="-120"/>
+              </a:rPr>
+              <a:t>1 000 €</a:t>
+            </a:r>
+            <a:endParaRPr lang="en-US" sz="1500" dirty="0"/>
+          </a:p>
+        </p:txBody>
+      </p:sp>
+      <p:sp>
+        <p:nvSpPr>
+          <p:cNvPr id="25" name="Text 22"/>
+          <p:cNvSpPr txBox="1"/>
+          <p:nvPr/>
+        </p:nvSpPr>
+        <p:spPr>
+          <a:xfrm>
+            <a:off x="10927080" y="4059936"/>
+            <a:ext cx="658368" cy="256032"/>
+          </a:xfrm>
+          <a:prstGeom prst="rect">
+            <a:avLst/>
+          </a:prstGeom>
+          <a:noFill/>
+          <a:ln/>
+        </p:spPr>
+        <p:txBody>
+          <a:bodyPr wrap="square" lIns="0" tIns="0" rIns="0" bIns="0" rtlCol="0" anchor="ctr"/>
+          <a:lstStyle/>
+          <a:p>
+            <a:pPr algn="r" indent="0" marL="0">
+              <a:buNone/>
+            </a:pPr>
+            <a:r>
+              <a:rPr lang="en-US" sz="1250" dirty="0">
+                <a:solidFill>
+                  <a:srgbClr val="5F757B"/>
+                </a:solidFill>
+                <a:latin typeface="Calibri" pitchFamily="34" charset="0"/>
+                <a:ea typeface="Calibri" pitchFamily="34" charset="-122"/>
+                <a:cs typeface="Calibri" pitchFamily="34" charset="-120"/>
+              </a:rPr>
+              <a:t>14 %</a:t>
+            </a:r>
+            <a:endParaRPr lang="en-US" sz="1250" dirty="0"/>
+          </a:p>
+        </p:txBody>
+      </p:sp>
+      <p:sp>
+        <p:nvSpPr>
+          <p:cNvPr id="26" name="Shape 23"/>
+          <p:cNvSpPr/>
+          <p:nvPr/>
+        </p:nvSpPr>
+        <p:spPr>
+          <a:xfrm>
+            <a:off x="6053328" y="4645152"/>
+            <a:ext cx="201168" cy="201168"/>
+          </a:xfrm>
+          <a:prstGeom prst="roundRect">
+            <a:avLst>
+              <a:gd name="adj" fmla="val 18182"/>
+            </a:avLst>
+          </a:prstGeom>
+          <a:solidFill>
+            <a:srgbClr val="7B4FA0"/>
+          </a:solidFill>
+          <a:ln/>
+        </p:spPr>
+      </p:sp>
+      <p:sp>
+        <p:nvSpPr>
+          <p:cNvPr id="27" name="Text 24"/>
+          <p:cNvSpPr txBox="1"/>
+          <p:nvPr/>
+        </p:nvSpPr>
+        <p:spPr>
+          <a:xfrm>
+            <a:off x="6400800" y="4590288"/>
+            <a:ext cx="2240280" cy="274320"/>
+          </a:xfrm>
+          <a:prstGeom prst="rect">
+            <a:avLst/>
+          </a:prstGeom>
+          <a:noFill/>
+          <a:ln/>
+        </p:spPr>
+        <p:txBody>
+          <a:bodyPr wrap="square" lIns="0" tIns="0" rIns="0" bIns="0" rtlCol="0" anchor="ctr"/>
+          <a:lstStyle/>
+          <a:p>
+            <a:pPr indent="0" marL="0">
+              <a:buNone/>
+            </a:pPr>
+            <a:r>
+              <a:rPr lang="en-US" sz="1400" b="1" dirty="0">
+                <a:solidFill>
+                  <a:srgbClr val="0F2E36"/>
+                </a:solidFill>
+                <a:latin typeface="Calibri" pitchFamily="34" charset="0"/>
+                <a:ea typeface="Calibri" pitchFamily="34" charset="-122"/>
+                <a:cs typeface="Calibri" pitchFamily="34" charset="-120"/>
+              </a:rPr>
+              <a:t>Activités</a:t>
+            </a:r>
+            <a:endParaRPr lang="en-US" sz="1400" dirty="0"/>
+          </a:p>
+        </p:txBody>
+      </p:sp>
+      <p:sp>
+        <p:nvSpPr>
+          <p:cNvPr id="28" name="Text 25"/>
+          <p:cNvSpPr txBox="1"/>
+          <p:nvPr/>
+        </p:nvSpPr>
+        <p:spPr>
+          <a:xfrm>
+            <a:off x="6400800" y="4846320"/>
+            <a:ext cx="3200400" cy="237744"/>
+          </a:xfrm>
+          <a:prstGeom prst="rect">
+            <a:avLst/>
+          </a:prstGeom>
+          <a:noFill/>
+          <a:ln/>
+        </p:spPr>
+        <p:txBody>
+          <a:bodyPr wrap="square" lIns="0" tIns="0" rIns="0" bIns="0" rtlCol="0" anchor="ctr"/>
+          <a:lstStyle/>
+          <a:p>
+            <a:pPr indent="0" marL="0">
+              <a:buNone/>
+            </a:pPr>
+            <a:r>
+              <a:rPr lang="en-US" sz="1050" dirty="0">
+                <a:solidFill>
+                  <a:srgbClr val="5F757B"/>
+                </a:solidFill>
+                <a:latin typeface="Calibri" pitchFamily="34" charset="0"/>
+                <a:ea typeface="Calibri" pitchFamily="34" charset="-122"/>
+                <a:cs typeface="Calibri" pitchFamily="34" charset="-120"/>
+              </a:rPr>
+              <a:t>Kayak guidé, bateaux d’archipel, canoë, élans, Vasa</a:t>
+            </a:r>
+            <a:endParaRPr lang="en-US" sz="1050" dirty="0"/>
+          </a:p>
+        </p:txBody>
+      </p:sp>
+      <p:sp>
+        <p:nvSpPr>
+          <p:cNvPr id="29" name="Text 26"/>
+          <p:cNvSpPr txBox="1"/>
+          <p:nvPr/>
+        </p:nvSpPr>
+        <p:spPr>
+          <a:xfrm>
+            <a:off x="9646920" y="4590288"/>
+            <a:ext cx="1188720" cy="274320"/>
+          </a:xfrm>
+          <a:prstGeom prst="rect">
+            <a:avLst/>
+          </a:prstGeom>
+          <a:noFill/>
+          <a:ln/>
+        </p:spPr>
+        <p:txBody>
+          <a:bodyPr wrap="square" lIns="0" tIns="0" rIns="0" bIns="0" rtlCol="0" anchor="ctr"/>
+          <a:lstStyle/>
+          <a:p>
+            <a:pPr algn="r" indent="0" marL="0">
+              <a:buNone/>
+            </a:pPr>
+            <a:r>
+              <a:rPr lang="en-US" sz="1500" b="1" dirty="0">
+                <a:solidFill>
+                  <a:srgbClr val="0F2E36"/>
+                </a:solidFill>
+                <a:latin typeface="Calibri" pitchFamily="34" charset="0"/>
+                <a:ea typeface="Calibri" pitchFamily="34" charset="-122"/>
+                <a:cs typeface="Calibri" pitchFamily="34" charset="-120"/>
+              </a:rPr>
+              <a:t>950 €</a:t>
+            </a:r>
+            <a:endParaRPr lang="en-US" sz="1500" dirty="0"/>
+          </a:p>
+        </p:txBody>
+      </p:sp>
+      <p:sp>
+        <p:nvSpPr>
+          <p:cNvPr id="30" name="Text 27"/>
+          <p:cNvSpPr txBox="1"/>
+          <p:nvPr/>
+        </p:nvSpPr>
+        <p:spPr>
+          <a:xfrm>
+            <a:off x="10927080" y="4608576"/>
+            <a:ext cx="658368" cy="256032"/>
+          </a:xfrm>
+          <a:prstGeom prst="rect">
+            <a:avLst/>
+          </a:prstGeom>
+          <a:noFill/>
+          <a:ln/>
+        </p:spPr>
+        <p:txBody>
+          <a:bodyPr wrap="square" lIns="0" tIns="0" rIns="0" bIns="0" rtlCol="0" anchor="ctr"/>
+          <a:lstStyle/>
+          <a:p>
+            <a:pPr algn="r" indent="0" marL="0">
+              <a:buNone/>
+            </a:pPr>
+            <a:r>
+              <a:rPr lang="en-US" sz="1250" dirty="0">
+                <a:solidFill>
+                  <a:srgbClr val="5F757B"/>
+                </a:solidFill>
+                <a:latin typeface="Calibri" pitchFamily="34" charset="0"/>
+                <a:ea typeface="Calibri" pitchFamily="34" charset="-122"/>
+                <a:cs typeface="Calibri" pitchFamily="34" charset="-120"/>
+              </a:rPr>
+              <a:t>13 %</a:t>
+            </a:r>
+            <a:endParaRPr lang="en-US" sz="1250" dirty="0"/>
+          </a:p>
+        </p:txBody>
+      </p:sp>
+      <p:sp>
+        <p:nvSpPr>
+          <p:cNvPr id="31" name="Shape 28"/>
+          <p:cNvSpPr/>
+          <p:nvPr/>
+        </p:nvSpPr>
+        <p:spPr>
+          <a:xfrm>
+            <a:off x="6053328" y="5230368"/>
+            <a:ext cx="5532120" cy="0"/>
+          </a:xfrm>
+          <a:prstGeom prst="line">
+            <a:avLst/>
+          </a:prstGeom>
+          <a:noFill/>
+          <a:ln w="12700">
+            <a:solidFill>
+              <a:srgbClr val="D5E3E6"/>
+            </a:solidFill>
+            <a:prstDash val="solid"/>
+          </a:ln>
+        </p:spPr>
+      </p:sp>
+      <p:sp>
+        <p:nvSpPr>
+          <p:cNvPr id="32" name="Text 29"/>
+          <p:cNvSpPr txBox="1"/>
+          <p:nvPr/>
+        </p:nvSpPr>
+        <p:spPr>
+          <a:xfrm>
+            <a:off x="6053328" y="5413248"/>
+            <a:ext cx="2743200" cy="237744"/>
+          </a:xfrm>
+          <a:prstGeom prst="rect">
+            <a:avLst/>
+          </a:prstGeom>
+          <a:noFill/>
+          <a:ln/>
+        </p:spPr>
+        <p:txBody>
+          <a:bodyPr wrap="square" lIns="0" tIns="0" rIns="0" bIns="0" rtlCol="0" anchor="ctr"/>
+          <a:lstStyle/>
+          <a:p>
+            <a:pPr indent="0" marL="0">
+              <a:buNone/>
+            </a:pPr>
+            <a:r>
+              <a:rPr lang="en-US" sz="1100" b="1" spc="220" kern="0" dirty="0">
+                <a:solidFill>
+                  <a:srgbClr val="5F757B"/>
+                </a:solidFill>
+                <a:latin typeface="Calibri" pitchFamily="34" charset="0"/>
+                <a:ea typeface="Calibri" pitchFamily="34" charset="-122"/>
+                <a:cs typeface="Calibri" pitchFamily="34" charset="-120"/>
+              </a:rPr>
+              <a:t>TOTAL ESTIMÉ</a:t>
+            </a:r>
+            <a:endParaRPr lang="en-US" sz="1100" dirty="0"/>
+          </a:p>
+        </p:txBody>
+      </p:sp>
+      <p:sp>
+        <p:nvSpPr>
+          <p:cNvPr id="33" name="Text 30"/>
+          <p:cNvSpPr txBox="1"/>
+          <p:nvPr/>
+        </p:nvSpPr>
+        <p:spPr>
+          <a:xfrm>
+            <a:off x="6053328" y="5669280"/>
+            <a:ext cx="3108960" cy="603504"/>
+          </a:xfrm>
+          <a:prstGeom prst="rect">
+            <a:avLst/>
+          </a:prstGeom>
+          <a:noFill/>
+          <a:ln/>
+        </p:spPr>
+        <p:txBody>
+          <a:bodyPr wrap="square" lIns="0" tIns="0" rIns="0" bIns="0" rtlCol="0" anchor="ctr"/>
+          <a:lstStyle/>
+          <a:p>
+            <a:pPr indent="0" marL="0">
+              <a:buNone/>
+            </a:pPr>
+            <a:r>
+              <a:rPr lang="en-US" sz="3400" b="1" dirty="0">
+                <a:solidFill>
+                  <a:srgbClr val="A83E27"/>
+                </a:solidFill>
+                <a:latin typeface="Cambria" pitchFamily="34" charset="0"/>
+                <a:ea typeface="Cambria" pitchFamily="34" charset="-122"/>
+                <a:cs typeface="Cambria" pitchFamily="34" charset="-120"/>
+              </a:rPr>
+              <a:t>≈ 7 150 €</a:t>
+            </a:r>
+            <a:endParaRPr lang="en-US" sz="3400" dirty="0"/>
+          </a:p>
+        </p:txBody>
+      </p:sp>
+      <p:sp>
+        <p:nvSpPr>
+          <p:cNvPr id="34" name="Text 31"/>
+          <p:cNvSpPr txBox="1"/>
+          <p:nvPr/>
+        </p:nvSpPr>
+        <p:spPr>
+          <a:xfrm>
+            <a:off x="9235440" y="5705856"/>
+            <a:ext cx="2350008" cy="274320"/>
+          </a:xfrm>
+          <a:prstGeom prst="rect">
+            <a:avLst/>
+          </a:prstGeom>
+          <a:noFill/>
+          <a:ln/>
+        </p:spPr>
+        <p:txBody>
+          <a:bodyPr wrap="square" lIns="0" tIns="0" rIns="0" bIns="0" rtlCol="0" anchor="ctr"/>
+          <a:lstStyle/>
+          <a:p>
+            <a:pPr algn="r" indent="0" marL="0">
+              <a:buNone/>
+            </a:pPr>
+            <a:r>
+              <a:rPr lang="en-US" sz="1300" dirty="0">
+                <a:solidFill>
+                  <a:srgbClr val="26383D"/>
+                </a:solidFill>
+                <a:latin typeface="Calibri" pitchFamily="34" charset="0"/>
+                <a:ea typeface="Calibri" pitchFamily="34" charset="-122"/>
+                <a:cs typeface="Calibri" pitchFamily="34" charset="-120"/>
+              </a:rPr>
+              <a:t>≈ 1 790 € par personne</a:t>
+            </a:r>
+            <a:endParaRPr lang="en-US" sz="1300" dirty="0"/>
+          </a:p>
+        </p:txBody>
+      </p:sp>
+      <p:sp>
+        <p:nvSpPr>
+          <p:cNvPr id="35" name="Text 32"/>
+          <p:cNvSpPr txBox="1"/>
+          <p:nvPr/>
+        </p:nvSpPr>
+        <p:spPr>
+          <a:xfrm>
+            <a:off x="8961120" y="5998464"/>
+            <a:ext cx="2624328" cy="274320"/>
+          </a:xfrm>
+          <a:prstGeom prst="rect">
+            <a:avLst/>
+          </a:prstGeom>
+          <a:noFill/>
+          <a:ln/>
+        </p:spPr>
+        <p:txBody>
+          <a:bodyPr wrap="square" lIns="0" tIns="0" rIns="0" bIns="0" rtlCol="0" anchor="ctr"/>
+          <a:lstStyle/>
+          <a:p>
+            <a:pPr algn="r" indent="0" marL="0">
+              <a:buNone/>
+            </a:pPr>
+            <a:r>
+              <a:rPr lang="en-US" sz="1300" dirty="0">
+                <a:solidFill>
+                  <a:srgbClr val="5F757B"/>
+                </a:solidFill>
+                <a:latin typeface="Calibri" pitchFamily="34" charset="0"/>
+                <a:ea typeface="Calibri" pitchFamily="34" charset="-122"/>
+                <a:cs typeface="Calibri" pitchFamily="34" charset="-120"/>
+              </a:rPr>
+              <a:t>≈ 550 € par jour pour quatre</a:t>
+            </a:r>
+            <a:endParaRPr lang="en-US" sz="1300" dirty="0"/>
+          </a:p>
+        </p:txBody>
+      </p:sp>
+      <p:sp>
+        <p:nvSpPr>
+          <p:cNvPr id="36" name="Text 33"/>
+          <p:cNvSpPr txBox="1"/>
+          <p:nvPr/>
+        </p:nvSpPr>
+        <p:spPr>
+          <a:xfrm>
+            <a:off x="566928" y="6355080"/>
+            <a:ext cx="5394960" cy="475488"/>
+          </a:xfrm>
+          <a:prstGeom prst="rect">
+            <a:avLst/>
+          </a:prstGeom>
+          <a:noFill/>
+          <a:ln/>
+        </p:spPr>
+        <p:txBody>
+          <a:bodyPr wrap="square" lIns="0" tIns="0" rIns="0" bIns="0" rtlCol="0" anchor="ctr"/>
+          <a:lstStyle/>
+          <a:p>
+            <a:pPr indent="0" marL="0">
+              <a:lnSpc>
+                <a:spcPct val="118000"/>
+              </a:lnSpc>
+              <a:buNone/>
+            </a:pPr>
+            <a:r>
+              <a:rPr lang="en-US" sz="1150" i="1" dirty="0">
+                <a:solidFill>
+                  <a:srgbClr val="5F757B"/>
+                </a:solidFill>
+                <a:latin typeface="Calibri" pitchFamily="34" charset="0"/>
+                <a:ea typeface="Calibri" pitchFamily="34" charset="-122"/>
+                <a:cs typeface="Calibri" pitchFamily="34" charset="-120"/>
+              </a:rPr>
+              <a:t>Estimation, pas un devis. Les deux postes qui bougeront le plus : le supplément d’abandon de la voiture (150 à 450 € selon les loueurs) et les deux nuits à Stockholm.</a:t>
+            </a:r>
+            <a:endParaRPr lang="en-US" sz="1150" dirty="0"/>
+          </a:p>
+        </p:txBody>
+      </p:sp>
+    </p:spTree>
+  </p:cSld>
+  <p:clrMapOvr>
+    <a:masterClrMapping/>
+  </p:clrMapOvr>
+</p:sld>
+</file>
+
+<file path=ppt/slides/slide29.xml><?xml version="1.0" encoding="utf-8"?>
+<p:sld xmlns:a="http://schemas.openxmlformats.org/drawingml/2006/main" xmlns:r="http://schemas.openxmlformats.org/officeDocument/2006/relationships" xmlns:p="http://schemas.openxmlformats.org/presentationml/2006/main">
+  <p:cSld name="Slide 29">
+    <p:bg>
+      <p:bgPr>
+        <a:solidFill>
           <a:srgbClr val="0F2E36"/>
         </a:solidFill>
       </p:bgPr>

</xml_diff>